<commit_message>
Add the deck's design system and slide specification
docs/design.md is the art direction (colour locks, type, chart rules, the
evidence-block pattern, six archetypes); docs/deck.md is 15 slides with copy,
the data behind each graphic, a verify line per slide, and ASSET markers with
capture instructions. The generated .pptx now carries dashed placeholder boxes
where a screenshot has to come from a person.

Co-Authored-By: Claude Opus 5 <noreply@anthropic.com>
</commit_message>
<xml_diff>
--- a/docs/VayuSetu.pptx
+++ b/docs/VayuSetu.pptx
@@ -3412,6 +3412,74 @@
                 <a:latin typeface="Segoe UI"/>
               </a:rPr>
               <a:t>—  Installs as an app; the service worker never caches a reading.</a:t>
+            </a:r>
+          </a:p>
+        </p:txBody>
+      </p:sp>
+      <p:sp>
+        <p:nvSpPr>
+          <p:cNvPr id="5" name="Rectangle 4"/>
+          <p:cNvSpPr/>
+          <p:nvPr/>
+        </p:nvSpPr>
+        <p:spPr>
+          <a:xfrm>
+            <a:off x="822960" y="5120640"/>
+            <a:ext cx="10545775" cy="1280160"/>
+          </a:xfrm>
+          <a:prstGeom prst="rect">
+            <a:avLst/>
+          </a:prstGeom>
+          <a:solidFill>
+            <a:srgbClr val="F0F2F6"/>
+          </a:solidFill>
+          <a:ln w="19050">
+            <a:solidFill>
+              <a:srgbClr val="DADDE4"/>
+            </a:solidFill>
+            <a:prstDash val="dash"/>
+          </a:ln>
+          <a:effectLst/>
+        </p:spPr>
+        <p:style>
+          <a:lnRef idx="1">
+            <a:schemeClr val="accent1"/>
+          </a:lnRef>
+          <a:fillRef idx="3">
+            <a:schemeClr val="accent1"/>
+          </a:fillRef>
+          <a:effectRef idx="2">
+            <a:schemeClr val="accent1"/>
+          </a:effectRef>
+          <a:fontRef idx="minor">
+            <a:schemeClr val="lt1"/>
+          </a:fontRef>
+        </p:style>
+        <p:txBody>
+          <a:bodyPr rtlCol="0" anchor="ctr" wrap="square" lIns="365760" rIns="365760"/>
+          <a:lstStyle/>
+          <a:p>
+            <a:pPr algn="ctr"/>
+            <a:r>
+              <a:rPr sz="1700" b="1">
+                <a:solidFill>
+                  <a:srgbClr val="434750"/>
+                </a:solidFill>
+                <a:latin typeface="Segoe UI"/>
+              </a:rPr>
+              <a:t>[ ASSET 3 (optional) — screenshot: resident view in Hindi ]</a:t>
+            </a:r>
+          </a:p>
+          <a:p>
+            <a:pPr algn="ctr"/>
+            <a:r>
+              <a:rPr sz="1300">
+                <a:solidFill>
+                  <a:srgbClr val="626772"/>
+                </a:solidFill>
+                <a:latin typeface="Segoe UI"/>
+              </a:rPr>
+              <a:t>/#/residents with the language set to हिन्दी, showing the band, the advice and the Listen button.</a:t>
             </a:r>
           </a:p>
         </p:txBody>
@@ -5404,61 +5472,68 @@
       </p:sp>
       <p:sp>
         <p:nvSpPr>
-          <p:cNvPr id="8" name="TextBox 7"/>
-          <p:cNvSpPr txBox="1"/>
+          <p:cNvPr id="8" name="Rectangle 7"/>
+          <p:cNvSpPr/>
           <p:nvPr/>
         </p:nvSpPr>
         <p:spPr>
           <a:xfrm>
-            <a:off x="822960" y="3657600"/>
+            <a:off x="822960" y="3566160"/>
             <a:ext cx="10545775" cy="2651760"/>
           </a:xfrm>
           <a:prstGeom prst="rect">
             <a:avLst/>
           </a:prstGeom>
-          <a:noFill/>
+          <a:solidFill>
+            <a:srgbClr val="F0F2F6"/>
+          </a:solidFill>
+          <a:ln w="19050">
+            <a:solidFill>
+              <a:srgbClr val="DADDE4"/>
+            </a:solidFill>
+            <a:prstDash val="dash"/>
+          </a:ln>
+          <a:effectLst/>
         </p:spPr>
-        <p:txBody>
-          <a:bodyPr wrap="square">
-            <a:spAutoFit/>
-          </a:bodyPr>
-          <a:lstStyle/>
-          <a:p>
-            <a:pPr algn="l">
-              <a:lnSpc>
-                <a:spcPct val="130000"/>
-              </a:lnSpc>
-              <a:spcAft>
-                <a:spcPts val="600"/>
-              </a:spcAft>
-            </a:pPr>
-            <a:r>
-              <a:rPr sz="1700" b="0">
+        <p:style>
+          <a:lnRef idx="1">
+            <a:schemeClr val="accent1"/>
+          </a:lnRef>
+          <a:fillRef idx="3">
+            <a:schemeClr val="accent1"/>
+          </a:fillRef>
+          <a:effectRef idx="2">
+            <a:schemeClr val="accent1"/>
+          </a:effectRef>
+          <a:fontRef idx="minor">
+            <a:schemeClr val="lt1"/>
+          </a:fontRef>
+        </p:style>
+        <p:txBody>
+          <a:bodyPr rtlCol="0" anchor="ctr" wrap="square" lIns="365760" rIns="365760"/>
+          <a:lstStyle/>
+          <a:p>
+            <a:pPr algn="ctr"/>
+            <a:r>
+              <a:rPr sz="1700" b="1">
                 <a:solidFill>
                   <a:srgbClr val="434750"/>
                 </a:solidFill>
                 <a:latin typeface="Segoe UI"/>
               </a:rPr>
-              <a:t>—  Gemini sees only measured evidence, and every number it cites is checked against the data in code before anyone sees it.</a:t>
-            </a:r>
-          </a:p>
-          <a:p>
-            <a:pPr algn="l">
-              <a:lnSpc>
-                <a:spcPct val="130000"/>
-              </a:lnSpc>
-              <a:spcAft>
-                <a:spcPts val="600"/>
-              </a:spcAft>
-            </a:pPr>
-            <a:r>
-              <a:rPr sz="1700" b="0">
-                <a:solidFill>
-                  <a:srgbClr val="434750"/>
-                </a:solidFill>
-                <a:latin typeface="Segoe UI"/>
-              </a:rPr>
-              <a:t>—  Two monitors reporting that hour failed the integrity checks and were left out of the average and the analysis.</a:t>
+              <a:t>[ ASSET 1 — screenshot: officials view at the hero hour ]</a:t>
+            </a:r>
+          </a:p>
+          <a:p>
+            <a:pPr algn="ctr"/>
+            <a:r>
+              <a:rPr sz="1300">
+                <a:solidFill>
+                  <a:srgbClr val="626772"/>
+                </a:solidFill>
+                <a:latin typeface="Segoe UI"/>
+              </a:rPr>
+              <a:t>Open /#/ on the live site, set the time to 12 Nov 2025 01:30 IST, capture 1600x1000 in the light theme. Must show the map with the wind fan, the four stat cards and the brief panel. Instructions: docs/deck.md.</a:t>
             </a:r>
           </a:p>
         </p:txBody>
@@ -6750,6 +6825,74 @@
                 <a:latin typeface="Segoe UI"/>
               </a:rPr>
               <a:t>—  Every agency and officer is a demo account: no real contact details exist in this codebase.</a:t>
+            </a:r>
+          </a:p>
+        </p:txBody>
+      </p:sp>
+      <p:sp>
+        <p:nvSpPr>
+          <p:cNvPr id="5" name="Rectangle 4"/>
+          <p:cNvSpPr/>
+          <p:nvPr/>
+        </p:nvSpPr>
+        <p:spPr>
+          <a:xfrm>
+            <a:off x="822960" y="5623560"/>
+            <a:ext cx="10545775" cy="868680"/>
+          </a:xfrm>
+          <a:prstGeom prst="rect">
+            <a:avLst/>
+          </a:prstGeom>
+          <a:solidFill>
+            <a:srgbClr val="F0F2F6"/>
+          </a:solidFill>
+          <a:ln w="19050">
+            <a:solidFill>
+              <a:srgbClr val="DADDE4"/>
+            </a:solidFill>
+            <a:prstDash val="dash"/>
+          </a:ln>
+          <a:effectLst/>
+        </p:spPr>
+        <p:style>
+          <a:lnRef idx="1">
+            <a:schemeClr val="accent1"/>
+          </a:lnRef>
+          <a:fillRef idx="3">
+            <a:schemeClr val="accent1"/>
+          </a:fillRef>
+          <a:effectRef idx="2">
+            <a:schemeClr val="accent1"/>
+          </a:effectRef>
+          <a:fontRef idx="minor">
+            <a:schemeClr val="lt1"/>
+          </a:fontRef>
+        </p:style>
+        <p:txBody>
+          <a:bodyPr rtlCol="0" anchor="ctr" wrap="square" lIns="365760" rIns="365760"/>
+          <a:lstStyle/>
+          <a:p>
+            <a:pPr algn="ctr"/>
+            <a:r>
+              <a:rPr sz="1700" b="1">
+                <a:solidFill>
+                  <a:srgbClr val="434750"/>
+                </a:solidFill>
+                <a:latin typeface="Segoe UI"/>
+              </a:rPr>
+              <a:t>[ ASSET 2 (optional) — screenshot: a refused closure ]</a:t>
+            </a:r>
+          </a:p>
+          <a:p>
+            <a:pPr algn="ctr"/>
+            <a:r>
+              <a:rPr sz="1300">
+                <a:solidFill>
+                  <a:srgbClr val="626772"/>
+                </a:solidFill>
+                <a:latin typeface="Segoe UI"/>
+              </a:rPr>
+              <a:t>/#/cases -&gt; submit a closure on the region-wide case with only a note. Capture the red refusal and its reason.</a:t>
             </a:r>
           </a:p>
         </p:txBody>

</xml_diff>

<commit_message>
Put live-site screenshots in the deck and add a finals cut
The three ASSET boxes now hold screenshots of the deployed site: the
officials view at the 12 Nov hero hour, a refused case closure, and the
resident view in Hindi. build_deck.py fits a picture from deck_assets/
into each box and still draws the placeholder when one is missing.

For the finals, where the live demo carries the talk, build_deck.py also
writes VayuSetu_finals.pptx (title and rigour, plus the three screenshot
slides as a backup), and FINALS.md is the five-minute run sheet.

SUBMISSION.md now links the public repository.

Co-Authored-By: Claude Opus 5.5 <noreply@anthropic.com>
</commit_message>
<xml_diff>
--- a/docs/VayuSetu.pptx
+++ b/docs/VayuSetu.pptx
@@ -3326,7 +3326,7 @@
         <p:spPr>
           <a:xfrm>
             <a:off x="822960" y="1828800"/>
-            <a:ext cx="10545775" cy="4480560"/>
+            <a:ext cx="5669280" cy="4480560"/>
           </a:xfrm>
           <a:prstGeom prst="rect">
             <a:avLst/>
@@ -3416,74 +3416,30 @@
           </a:p>
         </p:txBody>
       </p:sp>
-      <p:sp>
-        <p:nvSpPr>
-          <p:cNvPr id="5" name="Rectangle 4"/>
-          <p:cNvSpPr/>
+      <p:pic>
+        <p:nvPicPr>
+          <p:cNvPr id="5" name="Picture 4" descr="asset3.png"/>
+          <p:cNvPicPr>
+            <a:picLocks noChangeAspect="1"/>
+          </p:cNvPicPr>
           <p:nvPr/>
-        </p:nvSpPr>
+        </p:nvPicPr>
+        <p:blipFill>
+          <a:blip r:embed="rId2"/>
+          <a:stretch>
+            <a:fillRect/>
+          </a:stretch>
+        </p:blipFill>
         <p:spPr>
           <a:xfrm>
-            <a:off x="822960" y="5120640"/>
-            <a:ext cx="10545775" cy="1280160"/>
+            <a:off x="6766560" y="2452807"/>
+            <a:ext cx="4572000" cy="3232546"/>
           </a:xfrm>
           <a:prstGeom prst="rect">
             <a:avLst/>
           </a:prstGeom>
-          <a:solidFill>
-            <a:srgbClr val="F0F2F6"/>
-          </a:solidFill>
-          <a:ln w="19050">
-            <a:solidFill>
-              <a:srgbClr val="DADDE4"/>
-            </a:solidFill>
-            <a:prstDash val="dash"/>
-          </a:ln>
-          <a:effectLst/>
         </p:spPr>
-        <p:style>
-          <a:lnRef idx="1">
-            <a:schemeClr val="accent1"/>
-          </a:lnRef>
-          <a:fillRef idx="3">
-            <a:schemeClr val="accent1"/>
-          </a:fillRef>
-          <a:effectRef idx="2">
-            <a:schemeClr val="accent1"/>
-          </a:effectRef>
-          <a:fontRef idx="minor">
-            <a:schemeClr val="lt1"/>
-          </a:fontRef>
-        </p:style>
-        <p:txBody>
-          <a:bodyPr rtlCol="0" anchor="ctr" wrap="square" lIns="365760" rIns="365760"/>
-          <a:lstStyle/>
-          <a:p>
-            <a:pPr algn="ctr"/>
-            <a:r>
-              <a:rPr sz="1700" b="1">
-                <a:solidFill>
-                  <a:srgbClr val="434750"/>
-                </a:solidFill>
-                <a:latin typeface="Segoe UI"/>
-              </a:rPr>
-              <a:t>[ ASSET 3 (optional) — screenshot: resident view in Hindi ]</a:t>
-            </a:r>
-          </a:p>
-          <a:p>
-            <a:pPr algn="ctr"/>
-            <a:r>
-              <a:rPr sz="1300">
-                <a:solidFill>
-                  <a:srgbClr val="626772"/>
-                </a:solidFill>
-                <a:latin typeface="Segoe UI"/>
-              </a:rPr>
-              <a:t>/#/residents with the language set to हिन्दी, showing the band, the advice and the Listen button.</a:t>
-            </a:r>
-          </a:p>
-        </p:txBody>
-      </p:sp>
+      </p:pic>
     </p:spTree>
   </p:cSld>
   <p:clrMapOvr>
@@ -5470,74 +5426,30 @@
           </a:p>
         </p:txBody>
       </p:sp>
-      <p:sp>
-        <p:nvSpPr>
-          <p:cNvPr id="8" name="Rectangle 7"/>
-          <p:cNvSpPr/>
+      <p:pic>
+        <p:nvPicPr>
+          <p:cNvPr id="8" name="Picture 7" descr="asset1.png"/>
+          <p:cNvPicPr>
+            <a:picLocks noChangeAspect="1"/>
+          </p:cNvPicPr>
           <p:nvPr/>
-        </p:nvSpPr>
+        </p:nvPicPr>
+        <p:blipFill>
+          <a:blip r:embed="rId2"/>
+          <a:stretch>
+            <a:fillRect/>
+          </a:stretch>
+        </p:blipFill>
         <p:spPr>
           <a:xfrm>
-            <a:off x="822960" y="3566160"/>
-            <a:ext cx="10545775" cy="2651760"/>
+            <a:off x="3009460" y="3520440"/>
+            <a:ext cx="6172775" cy="3063240"/>
           </a:xfrm>
           <a:prstGeom prst="rect">
             <a:avLst/>
           </a:prstGeom>
-          <a:solidFill>
-            <a:srgbClr val="F0F2F6"/>
-          </a:solidFill>
-          <a:ln w="19050">
-            <a:solidFill>
-              <a:srgbClr val="DADDE4"/>
-            </a:solidFill>
-            <a:prstDash val="dash"/>
-          </a:ln>
-          <a:effectLst/>
         </p:spPr>
-        <p:style>
-          <a:lnRef idx="1">
-            <a:schemeClr val="accent1"/>
-          </a:lnRef>
-          <a:fillRef idx="3">
-            <a:schemeClr val="accent1"/>
-          </a:fillRef>
-          <a:effectRef idx="2">
-            <a:schemeClr val="accent1"/>
-          </a:effectRef>
-          <a:fontRef idx="minor">
-            <a:schemeClr val="lt1"/>
-          </a:fontRef>
-        </p:style>
-        <p:txBody>
-          <a:bodyPr rtlCol="0" anchor="ctr" wrap="square" lIns="365760" rIns="365760"/>
-          <a:lstStyle/>
-          <a:p>
-            <a:pPr algn="ctr"/>
-            <a:r>
-              <a:rPr sz="1700" b="1">
-                <a:solidFill>
-                  <a:srgbClr val="434750"/>
-                </a:solidFill>
-                <a:latin typeface="Segoe UI"/>
-              </a:rPr>
-              <a:t>[ ASSET 1 — screenshot: officials view at the hero hour ]</a:t>
-            </a:r>
-          </a:p>
-          <a:p>
-            <a:pPr algn="ctr"/>
-            <a:r>
-              <a:rPr sz="1300">
-                <a:solidFill>
-                  <a:srgbClr val="626772"/>
-                </a:solidFill>
-                <a:latin typeface="Segoe UI"/>
-              </a:rPr>
-              <a:t>Open /#/ on the live site, set the time to 12 Nov 2025 01:30 IST, capture 1600x1000 in the light theme. Must show the map with the wind fan, the four stat cards and the brief panel. Instructions: docs/deck.md.</a:t>
-            </a:r>
-          </a:p>
-        </p:txBody>
-      </p:sp>
+      </p:pic>
     </p:spTree>
   </p:cSld>
   <p:clrMapOvr>
@@ -6829,74 +6741,30 @@
           </a:p>
         </p:txBody>
       </p:sp>
-      <p:sp>
-        <p:nvSpPr>
-          <p:cNvPr id="5" name="Rectangle 4"/>
-          <p:cNvSpPr/>
+      <p:pic>
+        <p:nvPicPr>
+          <p:cNvPr id="5" name="Picture 4" descr="asset2.png"/>
+          <p:cNvPicPr>
+            <a:picLocks noChangeAspect="1"/>
+          </p:cNvPicPr>
           <p:nvPr/>
-        </p:nvSpPr>
+        </p:nvPicPr>
+        <p:blipFill>
+          <a:blip r:embed="rId2"/>
+          <a:stretch>
+            <a:fillRect/>
+          </a:stretch>
+        </p:blipFill>
         <p:spPr>
           <a:xfrm>
-            <a:off x="822960" y="5623560"/>
-            <a:ext cx="10545775" cy="868680"/>
+            <a:off x="2207846" y="5623560"/>
+            <a:ext cx="7776002" cy="868680"/>
           </a:xfrm>
           <a:prstGeom prst="rect">
             <a:avLst/>
           </a:prstGeom>
-          <a:solidFill>
-            <a:srgbClr val="F0F2F6"/>
-          </a:solidFill>
-          <a:ln w="19050">
-            <a:solidFill>
-              <a:srgbClr val="DADDE4"/>
-            </a:solidFill>
-            <a:prstDash val="dash"/>
-          </a:ln>
-          <a:effectLst/>
         </p:spPr>
-        <p:style>
-          <a:lnRef idx="1">
-            <a:schemeClr val="accent1"/>
-          </a:lnRef>
-          <a:fillRef idx="3">
-            <a:schemeClr val="accent1"/>
-          </a:fillRef>
-          <a:effectRef idx="2">
-            <a:schemeClr val="accent1"/>
-          </a:effectRef>
-          <a:fontRef idx="minor">
-            <a:schemeClr val="lt1"/>
-          </a:fontRef>
-        </p:style>
-        <p:txBody>
-          <a:bodyPr rtlCol="0" anchor="ctr" wrap="square" lIns="365760" rIns="365760"/>
-          <a:lstStyle/>
-          <a:p>
-            <a:pPr algn="ctr"/>
-            <a:r>
-              <a:rPr sz="1700" b="1">
-                <a:solidFill>
-                  <a:srgbClr val="434750"/>
-                </a:solidFill>
-                <a:latin typeface="Segoe UI"/>
-              </a:rPr>
-              <a:t>[ ASSET 2 (optional) — screenshot: a refused closure ]</a:t>
-            </a:r>
-          </a:p>
-          <a:p>
-            <a:pPr algn="ctr"/>
-            <a:r>
-              <a:rPr sz="1300">
-                <a:solidFill>
-                  <a:srgbClr val="626772"/>
-                </a:solidFill>
-                <a:latin typeface="Segoe UI"/>
-              </a:rPr>
-              <a:t>/#/cases -&gt; submit a closure on the region-wide case with only a note. Capture the red refusal and its reason.</a:t>
-            </a:r>
-          </a:p>
-        </p:txBody>
-      </p:sp>
+      </p:pic>
     </p:spTree>
   </p:cSld>
   <p:clrMapOvr>

</xml_diff>